<commit_message>
Add demo video link to README and presentation
Co-Authored-By: Claude Opus 5.5 <noreply@anthropic.com>
</commit_message>
<xml_diff>
--- a/VITV_Error404_1_Presentation.pptx
+++ b/VITV_Error404_1_Presentation.pptx
@@ -4935,7 +4935,7 @@
                   <a:srgbClr val="14142B"/>
                 </a:solidFill>
               </a:rPr>
-              <a:t>[demo video link]</a:t>
+              <a:t>https://youtu.be/WuWeffTKWeM</a:t>
             </a:r>
           </a:p>
           <a:p>
@@ -6618,7 +6618,7 @@
                   <a:srgbClr val="14142B"/>
                 </a:solidFill>
               </a:rPr>
-              <a:t>[demo video link]</a:t>
+              <a:t>https://youtu.be/WuWeffTKWeM</a:t>
             </a:r>
           </a:p>
         </p:txBody>

</xml_diff>